<commit_message>
v0.9.3 Beta: much faster ping test, pick your games on first launch, icons and flags, Overwatch 2, simpler layout, beta statistics
- Ping test runs every server at once and skips servers that don't answer (Deadlock 13 s -> 2 s, CS2 17 s -> 3 s)
- Welcome screen: name + the games you play
- Game icons, country flags, Overwatch 2 (Google Cloud regions)
- Simple layout without BOOST/Stop; status shows the locked server and its live ping
- Settings: two columns, choose games, one calm Back to normal button
- Beta usage statistics (Supabase, write-only) and a developer dashboard
- Updated guide, slides, PDFs and screenshots
</commit_message>
<xml_diff>
--- a/docs/2XPing-Slides-AR.pptx
+++ b/docs/2XPing-Slides-AR.pptx
@@ -118,7 +118,7 @@
   <p:extLst>
     <p:ext uri="{521415D9-36F7-43E2-AB2F-B90AF26B5E84}">
       <p14:sectionLst xmlns:p14="http://schemas.microsoft.com/office/powerpoint/2010/main">
-        <p14:section name="2X Ping" id="{39e9ea92-8361-e9e2-8ddd-33922932f860}">
+        <p14:section name="2X Ping" id="{71e4385b-043e-6dce-3cec-32b2f28aa021}">
           <p14:sldIdLst>
             <p14:sldId id="256"/>
             <p14:sldId id="257"/>
@@ -626,7 +626,7 @@
           <a:p>
             <a:r>
               <a:rPr lang="en-US" dirty="0"/>
-              <a:t>للمهتمين بالتقنية: البرنامج مكتوب بـ C# على .NET Framework الموجود في كل ويندوز، فما يحتاج تثبيت. يستخدم أدوات ويندوز المدمجة: جدار الحماية وpktmon وnetstat، وWireGuard للوسيط، وبيانات عامة من Steam وAWS وTencent.</a:t>
+              <a:t>للمهتمين بالتقنية: البرنامج مكتوب بـ C# على .NET Framework الموجود في كل ويندوز، فما يحتاج تثبيت. يستخدم أدوات ويندوز المدمجة: جدار الحماية وpktmon وnetstat، وWireGuard للوسيط، وبيانات عامة من Steam وAWS وTencent وGoogle.</a:t>
             </a:r>
             <a:endParaRPr lang="en-US" dirty="0"/>
           </a:p>
@@ -714,7 +714,7 @@
           <a:p>
             <a:r>
               <a:rPr lang="en-US" dirty="0"/>
-              <a:t>الأمان مهم للناس: البرنامج ما يلمس اللعبة، وكل تغيير ينشال لحاله، وما يجمع بيانات شخصية. وفيه زر «رجّع جهازي زي ما كان» يشيل كل شي ويتأكد بنفسه.</a:t>
+              <a:t>الأمان مهم للناس: البرنامج ما يلمس اللعبة، وكل تغيير ينشال لحاله. إحصائيات البيتا (الاسم والمدينة واللعبة والسيرفر) تنقال لك بوضوح أول ما تفتحه، وما فيها كلمات سر ولا ملفات. وفيه زر «رجّع كل شي طبيعي» يشيل كل شي ويتأكد بنفسه.</a:t>
             </a:r>
             <a:endParaRPr lang="en-US" dirty="0"/>
           </a:p>
@@ -978,7 +978,7 @@
           <a:p>
             <a:r>
               <a:rPr lang="en-US" dirty="0"/>
-              <a:t>اشرح الأدوات الأربع بسرعة: فحص البنق يوريك الوضع الحقيقي، و«العب عليه» يثبّتك على أحسن سيرفر بضغطة، و«على أي سيرفر أنا؟» يأكد لك، والبوست بالوسيط هو اللي ينزّل البنق فعلاً لو عندك سيرفر وسيط.</a:t>
+              <a:t>اشرح الأدوات الأربع بسرعة: فحص البنق يوريك الوضع الحقيقي، و«العب عليه» يثبّتك على أحسن سيرفر بضغطة، و«على أي سيرفر أنا؟» يأكد لك، والبوست بالوسيط في الوضع المتقدم هو اللي ينزّل البنق فعلاً لو عندك سيرفر وسيط. وأول مرة تفتحه تختار الألعاب اللي تلعبها، فما تشوف إلا هي.</a:t>
             </a:r>
             <a:endParaRPr lang="en-US" dirty="0"/>
           </a:p>
@@ -1154,7 +1154,7 @@
           <a:p>
             <a:r>
               <a:rPr lang="en-US" dirty="0"/>
-              <a:t>هنا كيف يقيس: لكل نوع ألعاب يجيب القائمة الرسمية لسيرفراتها. ألعاب Valve من Steam مباشرة، وألعاب AWS من مراكز Amazon، وArena Breakout من Tencent. يرسل أربع قياسات لكل سيرفر ويحسب البنق والتذبذب والفقد، والألوان توضح الحالة.</a:t>
+              <a:t>هنا كيف يقيس: لكل نوع ألعاب يجيب القائمة الرسمية لسيرفراتها. ألعاب Valve من Steam مباشرة، وألعاب AWS من مراكز Amazon، وArena Breakout من Tencent، وOverwatch 2 من Google. يفحص كل السيرفرات مع بعض، فالفحص كله ثانيتين ثلاث، والسيرفر اللي ما يرد يتخطاه. ويحسب البنق والتذبذب والفقد، والألوان توضح الحالة.</a:t>
             </a:r>
             <a:endParaRPr lang="en-US" dirty="0"/>
           </a:p>
@@ -1506,7 +1506,7 @@
           <a:p>
             <a:r>
               <a:rPr lang="en-US" dirty="0"/>
-              <a:t>البوست بالوسيط هو اللي ينزّل البنق فعلاً: بدل طريق شركة النت الطويل، ترافيك اللعبة بس يمشي من سيرفر VPS طريقه أقصر. يتجهّز بأمر واحد، والباقي من النت يمشي عادي. كن صريح: بدون وسيط ما نقدر نغيّر طريق شركة النت.</a:t>
+              <a:t>البوست بالوسيط موجود في الوضع المتقدم، وهو اللي ينزّل البنق فعلاً: بدل طريق شركة النت الطويل، ترافيك اللعبة بس يمشي من سيرفر VPS طريقه أقصر. يتجهّز بأمر واحد، والباقي من النت يمشي عادي. كن صريح: بدون وسيط ما نقدر نغيّر طريق شركة النت.</a:t>
             </a:r>
             <a:endParaRPr lang="en-US" dirty="0"/>
           </a:p>

</xml_diff>

<commit_message>
Docs for v0.11: guide, slides, PDFs and PowerPoint, roadmap, release checklist
- Guide and slides: the four released games, Overwatch 2 and Dead by Daylight server locks, the self-updating server check, automatic problem reports, new data sources
- Re-rendered the guide PDF, slides PDF, slide images and the PowerPoint
- ROADMAP for 0.11, docs/RELEASING.md checklist so every release updates everything linked to it

Co-Authored-By: Claude Opus 5.5 <noreply@anthropic.com>
</commit_message>
<xml_diff>
--- a/docs/2XPing-Slides-AR.pptx
+++ b/docs/2XPing-Slides-AR.pptx
@@ -118,7 +118,7 @@
   <p:extLst>
     <p:ext uri="{521415D9-36F7-43E2-AB2F-B90AF26B5E84}">
       <p14:sectionLst xmlns:p14="http://schemas.microsoft.com/office/powerpoint/2010/main">
-        <p14:section name="2X Ping" id="{733ecb2c-3bec-c36e-925d-fd0ba9bd0942}">
+        <p14:section name="2X Ping" id="{d61796da-1893-f1f0-ded5-1bae37eed438}">
           <p14:sldIdLst>
             <p14:sldId id="256"/>
             <p14:sldId id="257"/>
@@ -626,7 +626,7 @@
           <a:p>
             <a:r>
               <a:rPr lang="en-US" dirty="0"/>
-              <a:t>للمهتمين بالتقنية: البرنامج مكتوب بـ C# على .NET Framework الموجود في كل ويندوز، فما يحتاج تثبيت، والخط Readex Pro مدمج فيه. التحديث ينزل من GitHub ويتأكد من بصمة الملف قبل ما يستبدل نفسه. يستخدم أدوات ويندوز المدمجة: جدار الحماية وpktmon وnetstat، وWireGuard للوسيط، وبيانات عامة من Steam وAWS وTencent وGoogle.</a:t>
+              <a:t>للمهتمين بالتقنية: البرنامج مكتوب بـ C# على .NET Framework الموجود في كل ويندوز، فما يحتاج تثبيت، والخط Readex Pro مدمج فيه. التحديث ينزل من GitHub ويتأكد من بصمة الملف قبل ما يستبدل نفسه. يستخدم أدوات ويندوز المدمجة: جدار الحماية وpktmon وnetstat، وWireGuard للوسيط، وبيانات عامة من Steam وAmazon وGoogle وBlizzard وTencent. والمشاكل توصل تلقائي لقاعدة بيانات المطوّر.</a:t>
             </a:r>
             <a:endParaRPr lang="en-US" dirty="0"/>
           </a:p>
@@ -978,7 +978,7 @@
           <a:p>
             <a:r>
               <a:rPr lang="en-US" dirty="0"/>
-              <a:t>اشرح الأدوات الأربع بسرعة: فحص البنق يوريك الوضع الحقيقي، و«العب عليه» يثبّتك على أحسن سيرفر بضغطة، و«على أي سيرفر أنا؟» يأكد لك، والبوست بالوسيط في الوضع المتقدم هو اللي ينزّل البنق فعلاً لو عندك سيرفر وسيط. وأول مرة تفتحه تختار الألعاب اللي تلعبها، فما تشوف إلا هي. ولما تلعب صغّره، يروح جنب الساعة والتثبيت يبقى شغّال. والتحديث بضغطة وحدة.</a:t>
+              <a:t>اشرح الأدوات الأربع بسرعة: فحص البنق يوريك الوضع الحقيقي، و«العب عليه» يثبّتك على أحسن سيرفر بضغطة، و«على أي سيرفر أنا؟» يتحدّث لحاله ويأكد لك، وأي مشكلة يكتشفها توصلنا تلقائي بدون ما تقاطعك، والبوست بالوسيط في الوضع المتقدم هو اللي ينزّل البنق فعلاً لو عندك سيرفر وسيط. وأول مرة تفتحه تختار الألعاب اللي تلعبها، فما تشوف إلا هي. ولما تلعب صغّره، يروح جنب الساعة والتثبيت يبقى شغّال. والتحديث بضغطة وحدة.</a:t>
             </a:r>
             <a:endParaRPr lang="en-US" dirty="0"/>
           </a:p>
@@ -1154,7 +1154,7 @@
           <a:p>
             <a:r>
               <a:rPr lang="en-US" dirty="0"/>
-              <a:t>هنا كيف يقيس: لكل نوع ألعاب يجيب القائمة الرسمية لسيرفراتها. ألعاب Valve من Steam مباشرة، وألعاب AWS من مراكز Amazon، وArena Breakout من Tencent، وOverwatch 2 من Google. يفحص كل السيرفرات مع بعض، فالفحص كله ثانيتين ثلاث، والسيرفر اللي ما يرد يتخطاه. ويحسب البنق والتذبذب والفقد، والألوان توضح الحالة.</a:t>
+              <a:t>هنا كيف يقيس: لكل لعبة يجيب القائمة الرسمية لسيرفراتها. Deadlock من Steam مباشرة، وOverwatch 2 من قوائم Google وAmazon وشبكة Blizzard (15 مركز منها الدمام والدوحة والبحرين)، وDead by Daylight من مناطق Amazon GameLift بنفس الإشارة اللي تستخدمها اللعبة، وArena Breakout من Tencent. يفحص كل السيرفرات مع بعض، فالفحص كله ثانيتين ثلاث، والسيرفر اللي ما يرد يتخطاه. ويحسب البنق والتذبذب والفقد، والألوان توضح الحالة.</a:t>
             </a:r>
             <a:endParaRPr lang="en-US" dirty="0"/>
           </a:p>
@@ -1242,7 +1242,7 @@
           <a:p>
             <a:r>
               <a:rPr lang="en-US" dirty="0"/>
-              <a:t>التثبيت: البرنامج يحط قواعد في جدار حماية ويندوز تحجب المناطق اللي ما اخترتها. اللعبة تشوفها كأنها ما ترد، فما تحطك إلا في اختيارك. أكّد إنه ما يلمس ملفات اللعبة، وكل شي ينشال لما تفك التثبيت أو تقفل البرنامج.</a:t>
+              <a:t>التثبيت: البرنامج يحط قواعد في جدار حماية ويندوز تحجب السيرفرات اللي ما اخترتها، وفي أوفرواتش وديد باي دايلايت يحجب ترافيك المباراة بس، فالدخول والشات الصوتي والتدريب ما يتأثرون. العناوين من القوائم الرسمية وتتحدّث كل يوم. اللعبة تشوفها كأنها ما ترد، فما تحطك إلا في اختيارك. أكّد إنه ما يلمس ملفات اللعبة، وكل شي ينشال لما تفك التثبيت أو تقفل البرنامج.</a:t>
             </a:r>
             <a:endParaRPr lang="en-US" dirty="0"/>
           </a:p>
@@ -1330,7 +1330,7 @@
           <a:p>
             <a:r>
               <a:rPr lang="en-US" dirty="0"/>
-              <a:t>هادي الإجابة على سؤال: كيف أتأكد إنه فعلاً شغّال؟ وإنت داخل مباراة، البرنامج يراقب ترافيك اللعبة نفسها 15 ثانية، ويطابق عنوان السيرفر مع قائمة Valve، ويقولك اسم السيرفر وهل هو من اختيارك. جرّبناها وطلعت أمستردام ✓ وبنق اللعبة كان مطابق. نبّه إن القائمة والتدريب ما ينفعون.</a:t>
+              <a:t>هادي الإجابة على سؤال: كيف أتأكد إنه فعلاً شغّال؟ وإنت داخل مباراة، البرنامج يراقب ترافيك اللعبة نفسها 15 ثانية، ويطابق عنوان السيرفر مع قائمة سيرفرات اللعبة، ويقولك اسم السيرفر وهل هو من اختيارك. جرّبناها وطلعت أمستردام ✓ وبنق اللعبة كان مطابق. نبّه إن القائمة والتدريب ما ينفعون.</a:t>
             </a:r>
             <a:endParaRPr lang="en-US" dirty="0"/>
           </a:p>

</xml_diff>

<commit_message>
Slides for v0.12.0: simple screen steps, route-aware Deadlock lock, honest server check with -condebug, match reports, realistic player numbers, Hijazi wording; images, PDF and PPTX re-rendered
Co-Authored-By: Claude Opus 5.5 <noreply@anthropic.com>
</commit_message>
<xml_diff>
--- a/docs/2XPing-Slides-AR.pptx
+++ b/docs/2XPing-Slides-AR.pptx
@@ -118,7 +118,7 @@
   <p:extLst>
     <p:ext uri="{521415D9-36F7-43E2-AB2F-B90AF26B5E84}">
       <p14:sectionLst xmlns:p14="http://schemas.microsoft.com/office/powerpoint/2010/main">
-        <p14:section name="2X Ping" id="{d61796da-1893-f1f0-ded5-1bae37eed438}">
+        <p14:section name="2X Ping" id="{dd1bbf8f-3382-900e-23c5-3efb69ff3125}">
           <p14:sldIdLst>
             <p14:sldId id="256"/>
             <p14:sldId id="257"/>
@@ -538,7 +538,7 @@
           <a:p>
             <a:r>
               <a:rPr lang="en-US" dirty="0"/>
-              <a:t>رحّب بالحضور. هادا 2X Ping، برنامج مجاني سويته للاعبين على ويندوز، هدفه بنق أقل ولعب أحلى. البرنامج لسا بيتا، يعني نجرّب ونطوّر مع الناس.</a:t>
+              <a:t>رحّب بالحضور. هادا 2X Ping، برنامج مجاني سويته للاعبين على ويندوز، هدفه بنق أقل وبحث أسرع. البرنامج لسا بيتا (0.12)، يعني نجرّب ونطوّر مع الناس.</a:t>
             </a:r>
             <a:endParaRPr lang="en-US" dirty="0"/>
           </a:p>
@@ -626,7 +626,7 @@
           <a:p>
             <a:r>
               <a:rPr lang="en-US" dirty="0"/>
-              <a:t>للمهتمين بالتقنية: البرنامج مكتوب بـ C# على .NET Framework الموجود في كل ويندوز، فما يحتاج تثبيت، والخط Readex Pro مدمج فيه. التحديث ينزل من GitHub ويتأكد من بصمة الملف قبل ما يستبدل نفسه. يستخدم أدوات ويندوز المدمجة: جدار الحماية وpktmon وnetstat، وWireGuard للوسيط، وبيانات عامة من Steam وAmazon وGoogle وBlizzard وTencent. والمشاكل توصل تلقائي لقاعدة بيانات المطوّر.</a:t>
+              <a:t>للمهتمين بالتقنية: البرنامج مكتوب بـ C# على .NET Framework الموجود في كل ويندوز، فما يحتاج تثبيت، والخط Readex Pro مدمج فيه. التحديث ينزل من GitHub ويتأكد من بصمة الملف قبل ما يستبدل نفسه، ويرجّع النسخة القديمة لو صار خطأ. يستخدم أدوات ويندوز المدمجة: جدار الحماية وpktmon، وسجل Deadlock لو شغّلت -condebug، وWireGuard للوسيط، وبيانات عامة من Steam وAmazon وGoogle وBlizzard وTencent. والمشاكل وتقارير المباريات توصل تلقائي لقاعدة بيانات المطوّر.</a:t>
             </a:r>
             <a:endParaRPr lang="en-US" dirty="0"/>
           </a:p>
@@ -714,7 +714,7 @@
           <a:p>
             <a:r>
               <a:rPr lang="en-US" dirty="0"/>
-              <a:t>الأمان مهم للناس: البرنامج ما يلمس اللعبة، وكل تغيير ينشال لحاله. إحصائيات البيتا (الاسم والمدينة واللعبة والسيرفر) تنقال لك بوضوح أول ما تفتحه، وما فيها كلمات سر ولا ملفات. وفيه زر «رجّع كل شي طبيعي» يشيل كل شي ويتأكد بنفسه.</a:t>
+              <a:t>الأمان مهم للناس: البرنامج ما يعدّل ملفات اللعبة ولا يلمس ذاكرتها، وكل تغيير ينشال لحاله. إحصائيات البيتا (الاسم والمدينة ومواصفات الجهاز واللعبة والسيرفر وتقرير قصير عن كل مباراة) تنقال لك بوضوح أول ما تفتحه، وما فيها كلمات سر ولا ملفات ولا عناوين. وفيه زر «رجّع كل شي طبيعي» يشيل كل شي ويتأكد بنفسه.</a:t>
             </a:r>
             <a:endParaRPr lang="en-US" dirty="0"/>
           </a:p>
@@ -890,7 +890,7 @@
           <a:p>
             <a:r>
               <a:rPr lang="en-US" dirty="0"/>
-              <a:t>ابدأ بالمشكلة: كلنا نحس إن البنق عالي أحياناً بدون سبب. المثال هنا من جهازي: دبي أقرب بكثير من فرانكفورت، لكن البنق لها أعلى. السبب إن شركة النت توجّه الترافيك عن طريق أوروبا ويرجع. يعني المسافة مو كل شي، الطريق هو الأهم.</a:t>
+              <a:t>ابدأ بالمشكلة: كلنا نحس إن البنق عالي أحياناً بدون سبب. المثال هنا من جهازي: دبي أقرب بكثير من فرانكفورت، لكن البنق لها أعلى. السبب إن شركة النت توجّه الاتصال عن طريق أوروبا ويرجع. يعني المسافة مو كل شي، الطريق هو الأهم.</a:t>
             </a:r>
             <a:endParaRPr lang="en-US" dirty="0"/>
           </a:p>
@@ -978,7 +978,7 @@
           <a:p>
             <a:r>
               <a:rPr lang="en-US" dirty="0"/>
-              <a:t>اشرح الأدوات الأربع بسرعة: فحص البنق يوريك الوضع الحقيقي، و«العب عليه» يثبّتك على أحسن سيرفر بضغطة، و«على أي سيرفر أنا؟» يتحدّث لحاله ويأكد لك، وأي مشكلة يكتشفها توصلنا تلقائي بدون ما تقاطعك، والبوست بالوسيط في الوضع المتقدم هو اللي ينزّل البنق فعلاً لو عندك سيرفر وسيط. وأول مرة تفتحه تختار الألعاب اللي تلعبها، فما تشوف إلا هي. ولما تلعب صغّره، يروح جنب الساعة والتثبيت يبقى شغّال. والتحديث بضغطة وحدة.</a:t>
+              <a:t>اشرح الأدوات الأربع بسرعة: فحص البنق يوريك الوضع الحقيقي، و«العب على ...» يثبّتك على المنطقة اللي تبغاها بضغطة، والبطاقة تقولك وإنت داخل المباراة وين تلعب وهل هي من اختيارك، والتسريع بالوسيط في الوضع المتقدم هو اللي ينزّل البنق فعلاً لو عندك سيرفر وسيط. والشاشة الرئيسية صارت بطاقة وحدة تقولك وش يصير، وبعد التثبيت تقولك بنقك المتوقع. وتقرير كل مباراة والمشاكل توصلنا لحالها بدون ما تقاطعك. ولما تلعب صغّره، يبقى في شريط المهام والتثبيت شغّال. والتحديث بضغطة وحدة.</a:t>
             </a:r>
             <a:endParaRPr lang="en-US" dirty="0"/>
           </a:p>
@@ -1066,7 +1066,7 @@
           <a:p>
             <a:r>
               <a:rPr lang="en-US" dirty="0"/>
-              <a:t>الاستخدام سهل: أربع خطوات. البرنامج يفحص لحاله ويقترح أحسن سيرفر، يعني أقل بنق وفيه لاعبين كفاية. تضغط «العب عليه»، ترجع تفتح اللعبة، وتتأكد. ولو حد يبغى تفاصيل أكثر فيه وضع متقدم من الإعدادات.</a:t>
+              <a:t>الاستخدام سهل: أربع خطوات. البرنامج يفحص لحاله ويقترح أحسن منطقة، يعني أقل بنق وفيها لاعبين كفاية. تعلّم المنطقة وتضغط «العب على أوروبا» مثلاً، تقفل اللعبة وتفتحها، ولما تدخل مباراة البطاقة تقولك «تلعب دحين في أوروبا ✓». ولو حد يبغى تفاصيل أكثر فيه وضع متقدم من الإعدادات.</a:t>
             </a:r>
             <a:endParaRPr lang="en-US" dirty="0"/>
           </a:p>
@@ -1154,7 +1154,7 @@
           <a:p>
             <a:r>
               <a:rPr lang="en-US" dirty="0"/>
-              <a:t>هنا كيف يقيس: لكل لعبة يجيب القائمة الرسمية لسيرفراتها. Deadlock من Steam مباشرة، وOverwatch 2 من قوائم Google وAmazon وشبكة Blizzard (15 مركز منها الدمام والدوحة والبحرين)، وDead by Daylight من مناطق Amazon GameLift بنفس الإشارة اللي تستخدمها اللعبة، وArena Breakout من Tencent. يفحص كل السيرفرات مع بعض، فالفحص كله ثانيتين ثلاث، والسيرفر اللي ما يرد يتخطاه. ويحسب البنق والتذبذب والفقد، والألوان توضح الحالة.</a:t>
+              <a:t>هنا كيف يقيس: لكل لعبة يجيب القائمة الرسمية لسيرفراتها. Deadlock من Steam مباشرة، ويحسب أقصر طريق لكل منطقة داخل شبكة Valve (مثلاً من الرياض لأوروبا عن طريق دبي). Overwatch 2 من قوائم Google وAmazon وشبكة Blizzard (15 مركز منها الدمام والدوحة والبحرين)، وDead by Daylight من مناطق Amazon GameLift بنفس الإشارة اللي تستخدمها اللعبة، وArena Breakout من Tencent. يفحص كل السيرفرات مع بعض، فالفحص كله ثانيتين ثلاث، والسيرفر اللي ما يرد يتخطاه. ويحسب البنق والتذبذب والفقد، والألوان توضح الحالة.</a:t>
             </a:r>
             <a:endParaRPr lang="en-US" dirty="0"/>
           </a:p>
@@ -1242,7 +1242,7 @@
           <a:p>
             <a:r>
               <a:rPr lang="en-US" dirty="0"/>
-              <a:t>التثبيت: البرنامج يحط قواعد في جدار حماية ويندوز تحجب السيرفرات اللي ما اخترتها، وفي أوفرواتش وديد باي دايلايت يحجب ترافيك المباراة بس، فالدخول والشات الصوتي والتدريب ما يتأثرون. العناوين من القوائم الرسمية وتتحدّث كل يوم. اللعبة تشوفها كأنها ما ترد، فما تحطك إلا في اختيارك. أكّد إنه ما يلمس ملفات اللعبة، وكل شي ينشال لما تفك التثبيت أو تقفل البرنامج.</a:t>
+              <a:t>التثبيت: البرنامج يحط قواعد في جدار حماية ويندوز تحجب السيرفرات اللي ما اخترتها، فاللعبة تشوفها كأنها ما ترد وما تحطك إلا في اختيارك. في Deadlock التثبيت صارم ويعرف الطريق: مدخل زي دبي يبقى مفتوح لو يوصل لمناطقك بس، عشان بنقك يبقى أقل، والبطاقة تقولك بنقك المتوقع قبل وبعد ما تثبّت. وفي الإعدادات «دبي كطريق لأوروبا» لو تبغى تقفل دبي. في أوفرواتش وديد باي دايلايت (قيد التطوير) يحجب اتصال المباراة بس، فالدخول والشات الصوتي والتدريب ما يتأثرون. أكّد إنه ما يلمس ملفات اللعبة، وكل شي ينشال لما تفك التثبيت أو تقفل البرنامج.</a:t>
             </a:r>
             <a:endParaRPr lang="en-US" dirty="0"/>
           </a:p>
@@ -1330,7 +1330,7 @@
           <a:p>
             <a:r>
               <a:rPr lang="en-US" dirty="0"/>
-              <a:t>هادي الإجابة على سؤال: كيف أتأكد إنه فعلاً شغّال؟ وإنت داخل مباراة، البرنامج يراقب ترافيك اللعبة نفسها 15 ثانية، ويطابق عنوان السيرفر مع قائمة سيرفرات اللعبة، ويقولك اسم السيرفر وهل هو من اختيارك. جرّبناها وطلعت أمستردام ✓ وبنق اللعبة كان مطابق. نبّه إن القائمة والتدريب ما ينفعون.</a:t>
+              <a:t>هادي الإجابة على سؤال: كيف أتأكد إنه فعلاً شغّال؟ وإنت داخل مباراة، البرنامج يراقب اتصال اللعبة نفسها، ياخذ السيرفر اللي عليه نص الاتصال أو أكثر، ويطابقه مع قائمة سيرفرات اللعبة، والبطاقة تقولك وين تلعب وهل هي من اختيارك. في Deadlock لو اللعبة داخلة من وسيط زي دبي، سيرفر المباراة ما يبان، فالبطاقة تقول كذا بصراحة بدل ما تخمّن. ولو ضفت -condebug لخيارات التشغيل، البرنامج يقرا سجل اللعبة ويقولك المدينة بالضبط، مثلاً فرانكفورت. وبعد دقيقة من كل مباراة يوصلنا تقرير قصير لحاله، عشان نتأكد إن التثبيت يوفي بوعده. نبّه إن القائمة والتدريب ما ينفعون.</a:t>
             </a:r>
             <a:endParaRPr lang="en-US" dirty="0"/>
           </a:p>
@@ -1418,7 +1418,7 @@
           <a:p>
             <a:r>
               <a:rPr lang="en-US" dirty="0"/>
-              <a:t>عدد اللاعبين تقريبي: نحسبه من عدد المباريات اللي بدت في آخر ساعة في كل منطقة، ضرب 12 لاعب، ضرب نص ساعة متوسط المباراة. السيرفرات متجمّعة تحت منطقتها، والمنطقة الأكثر لاعبين عليها نجمة. خلّهم يعرفون إنها أرقام تقديرية مو رسمية.</a:t>
+              <a:t>عدد اللاعبين تقريبي بس صار واقعي: نحسبه من كل المباريات اللي تنلعب في اليوم، ضرب 12 لاعب، ضرب متوسط المباراة 32 دقيقة، ويتعدّل حسب زحمة الساعة، وينضاف له اللي في القوائم والانتظار، فيطلع تقريباً 49 ألف بدل ألفين. نصيب كل منطقة ووقت الانتظار من المباريات الشغّالة دحين. والأرقام نسخة وحدة مشتركة لكل الأجهزة عن طريق قاعدة بيانات المطوّر. خلّهم يعرفون إنها أرقام تقديرية مو رسمية.</a:t>
             </a:r>
             <a:endParaRPr lang="en-US" dirty="0"/>
           </a:p>
@@ -1506,7 +1506,7 @@
           <a:p>
             <a:r>
               <a:rPr lang="en-US" dirty="0"/>
-              <a:t>البوست بالوسيط موجود في الوضع المتقدم، وهو اللي ينزّل البنق فعلاً: بدل طريق شركة النت الطويل، ترافيك اللعبة بس يمشي من سيرفر VPS طريقه أقصر. يتجهّز بأمر واحد، والباقي من النت يمشي عادي. كن صريح: بدون وسيط ما نقدر نغيّر طريق شركة النت.</a:t>
+              <a:t>التسريع بالوسيط موجود في الوضع المتقدم، وهو اللي ينزّل البنق فعلاً: بدل طريق شركة النت الطويل، اتصال اللعبة بس يمشي من سيرفر VPS طريقه أقصر. يتجهّز بأمر واحد، والباقي من النت يمشي عادي. كن صريح: بدون وسيط ما نقدر نغيّر طريق شركة النت.</a:t>
             </a:r>
             <a:endParaRPr lang="en-US" dirty="0"/>
           </a:p>

</xml_diff>

<commit_message>
Slides for v0.13.0: version, game list without Overwatch (Arena Breakout server check only, Dead by Daylight in development), contact form, anonymous statistics; images, PDF and PPTX re-rendered
Co-Authored-By: Claude Opus 5.5 <noreply@anthropic.com>
</commit_message>
<xml_diff>
--- a/docs/2XPing-Slides-AR.pptx
+++ b/docs/2XPing-Slides-AR.pptx
@@ -118,7 +118,7 @@
   <p:extLst>
     <p:ext uri="{521415D9-36F7-43E2-AB2F-B90AF26B5E84}">
       <p14:sectionLst xmlns:p14="http://schemas.microsoft.com/office/powerpoint/2010/main">
-        <p14:section name="2X Ping" id="{dd1bbf8f-3382-900e-23c5-3efb69ff3125}">
+        <p14:section name="2X Ping" id="{89731369-fddd-2a9d-620d-fc5162b474ad}">
           <p14:sldIdLst>
             <p14:sldId id="256"/>
             <p14:sldId id="257"/>
@@ -538,7 +538,7 @@
           <a:p>
             <a:r>
               <a:rPr lang="en-US" dirty="0"/>
-              <a:t>رحّب بالحضور. هادا 2X Ping، برنامج مجاني سويته للاعبين على ويندوز، هدفه بنق أقل وبحث أسرع. البرنامج لسا بيتا (0.12)، يعني نجرّب ونطوّر مع الناس.</a:t>
+              <a:t>رحّب بالحضور. هادا 2X Ping، برنامج مجاني سويته للاعبين على ويندوز، هدفه بنق أقل وبحث أسرع. البرنامج بيتا (0.13)، يعني نجرّب ونطوّر مع الناس.</a:t>
             </a:r>
             <a:endParaRPr lang="en-US" dirty="0"/>
           </a:p>
@@ -626,7 +626,7 @@
           <a:p>
             <a:r>
               <a:rPr lang="en-US" dirty="0"/>
-              <a:t>للمهتمين بالتقنية: البرنامج مكتوب بـ C# على .NET Framework الموجود في كل ويندوز، فما يحتاج تثبيت، والخط Readex Pro مدمج فيه. التحديث ينزل من GitHub ويتأكد من بصمة الملف قبل ما يستبدل نفسه، ويرجّع النسخة القديمة لو صار خطأ. يستخدم أدوات ويندوز المدمجة: جدار الحماية وpktmon، وسجل Deadlock لو شغّلت -condebug، وWireGuard للوسيط، وبيانات عامة من Steam وAmazon وGoogle وBlizzard وTencent. والمشاكل وتقارير المباريات توصل تلقائي لقاعدة بيانات المطوّر.</a:t>
+              <a:t>للمهتمين بالتقنية: البرنامج مكتوب بـ C# على .NET Framework الموجود في كل ويندوز، فما يحتاج تثبيت، والخط Readex Pro مدمج فيه. التحديث ينزل من GitHub ويتأكد من بصمة الملف قبل ما يستبدل نفسه، ويرجّع النسخة القديمة لو صار خطأ. يستخدم أدوات ويندوز المدمجة: جدار الحماية وpktmon، وسجل Deadlock لو شغّلت -condebug، وWireGuard للوسيط، وبيانات عامة من Steam وAmazon وTencent. والمشاكل وتقارير المباريات توصل تلقائي لقاعدة بيانات المطوّر.</a:t>
             </a:r>
             <a:endParaRPr lang="en-US" dirty="0"/>
           </a:p>
@@ -714,7 +714,7 @@
           <a:p>
             <a:r>
               <a:rPr lang="en-US" dirty="0"/>
-              <a:t>الأمان مهم للناس: البرنامج ما يعدّل ملفات اللعبة ولا يلمس ذاكرتها، وكل تغيير ينشال لحاله. إحصائيات البيتا (الاسم والمدينة ومواصفات الجهاز واللعبة والسيرفر وتقرير قصير عن كل مباراة) تنقال لك بوضوح أول ما تفتحه، وما فيها كلمات سر ولا ملفات ولا عناوين. وفيه زر «رجّع كل شي طبيعي» يشيل كل شي ويتأكد بنفسه.</a:t>
+              <a:t>الأمان مهم للناس: البرنامج ما يعدّل ملفات اللعبة ولا يلمس ذاكرتها، وكل تغيير ينشال لحاله. إحصائيات البيتا (البنق والأخطاء وتقرير قصير عن كل مباراة) تنقال لك أول ما تفتحه، وتقدر تخليها مجهولة من الإعدادات، وما فيها كلمات سر ولا ملفات ولا عناوين. وفيه زر «رجّع كل شي طبيعي» يشيل كل شي ويتأكد بنفسه.</a:t>
             </a:r>
             <a:endParaRPr lang="en-US" dirty="0"/>
           </a:p>
@@ -802,7 +802,7 @@
           <a:p>
             <a:r>
               <a:rPr lang="en-US" dirty="0"/>
-              <a:t>اختم: البرنامج بيتا ومجاني، وأهم شي رأيهم. من زر «تواصل معنا» يبلّغون أو يقترحون. التحميل من صفحة GitHub، وديسكوردي 2x.x. اشكرهم.</a:t>
+              <a:t>اختم: البرنامج بيتا ومجاني، وأهم شي رأيهم. من زر «تواصل معنا» يكتبون مشكلة أو فكرة أو سؤال ويضغطون «أرسل»، وتوصلنا مباشرة. التحميل من صفحة GitHub، وديسكوردي 2x.x. اشكرهم.</a:t>
             </a:r>
             <a:endParaRPr lang="en-US" dirty="0"/>
           </a:p>
@@ -1154,7 +1154,7 @@
           <a:p>
             <a:r>
               <a:rPr lang="en-US" dirty="0"/>
-              <a:t>هنا كيف يقيس: لكل لعبة يجيب القائمة الرسمية لسيرفراتها. Deadlock من Steam مباشرة، ويحسب أقصر طريق لكل منطقة داخل شبكة Valve (مثلاً من الرياض لأوروبا عن طريق دبي). Overwatch 2 من قوائم Google وAmazon وشبكة Blizzard (15 مركز منها الدمام والدوحة والبحرين)، وDead by Daylight من مناطق Amazon GameLift بنفس الإشارة اللي تستخدمها اللعبة، وArena Breakout من Tencent. يفحص كل السيرفرات مع بعض، فالفحص كله ثانيتين ثلاث، والسيرفر اللي ما يرد يتخطاه. ويحسب البنق والتذبذب والفقد، والألوان توضح الحالة.</a:t>
+              <a:t>هنا كيف يقيس: لكل لعبة يجيب القائمة الرسمية لسيرفراتها. Deadlock من Steam مباشرة، ويحسب أقصر طريق لكل منطقة داخل شبكة Valve (مثلاً من الرياض لأوروبا عن طريق دبي). Dead by Daylight (قيد التطوير) من مناطق Amazon GameLift بنفس الإشارة اللي تستخدمها اللعبة، وArena Breakout من Tencent، وفيها البرنامج يعرض سيرفرك بس لأن اللعبة تختار المنطقة من حسابك. يفحص كل السيرفرات مع بعض، فالفحص كله ثانيتين ثلاث، والسيرفر اللي ما يرد يتخطاه. ويحسب البنق والتذبذب والفقد، والألوان توضح الحالة.</a:t>
             </a:r>
             <a:endParaRPr lang="en-US" dirty="0"/>
           </a:p>
@@ -1242,7 +1242,7 @@
           <a:p>
             <a:r>
               <a:rPr lang="en-US" dirty="0"/>
-              <a:t>التثبيت: البرنامج يحط قواعد في جدار حماية ويندوز تحجب السيرفرات اللي ما اخترتها، فاللعبة تشوفها كأنها ما ترد وما تحطك إلا في اختيارك. في Deadlock التثبيت صارم ويعرف الطريق: مدخل زي دبي يبقى مفتوح لو يوصل لمناطقك بس، عشان بنقك يبقى أقل، والبطاقة تقولك بنقك المتوقع قبل وبعد ما تثبّت. وفي الإعدادات «دبي كطريق لأوروبا» لو تبغى تقفل دبي. في أوفرواتش وديد باي دايلايت (قيد التطوير) يحجب اتصال المباراة بس، فالدخول والشات الصوتي والتدريب ما يتأثرون. أكّد إنه ما يلمس ملفات اللعبة، وكل شي ينشال لما تفك التثبيت أو تقفل البرنامج.</a:t>
+              <a:t>التثبيت: البرنامج يحط قواعد في جدار حماية ويندوز تحجب السيرفرات اللي ما اخترتها، فاللعبة تشوفها كأنها ما ترد وما تحطك إلا في اختيارك. في Deadlock التثبيت صارم ويعرف الطريق: مدخل زي دبي يبقى مفتوح لو يوصل لمناطقك بس، عشان بنقك يبقى أقل، والبطاقة تقولك بنقك المتوقع قبل وبعد ما تثبّت. وفي الإعدادات «دبي كطريق لأوروبا» لو تبغى تقفل دبي. في ديد باي دايلايت (قيد التطوير) يحجب اتصال المباراة بس، فالدخول والشات الصوتي والتدريب ما يتأثرون. أكّد إنه ما يلمس ملفات اللعبة، وكل شي ينشال لما تفك التثبيت أو تقفل البرنامج.</a:t>
             </a:r>
             <a:endParaRPr lang="en-US" dirty="0"/>
           </a:p>

</xml_diff>